<commit_message>
Provide files for participants
</commit_message>
<xml_diff>
--- a/slides/session-2.pptx
+++ b/slides/session-2.pptx
@@ -247,7 +247,7 @@
           <a:p>
             <a:fld id="{C1B00CD9-D39B-4600-9C3E-8CF0197F5D83}" type="datetime4">
               <a:rPr lang="cs-CZ" smtClean="0"/>
-              <a:t>9. června 2026</a:t>
+              <a:t>15. června 2026</a:t>
             </a:fld>
             <a:endParaRPr lang="cs-CZ"/>
           </a:p>
@@ -428,7 +428,7 @@
           <a:p>
             <a:fld id="{474C8EE8-AAF6-48AB-BE2E-E03BD44C148F}" type="datetime4">
               <a:rPr lang="cs-CZ" smtClean="0"/>
-              <a:t>9. června 2026</a:t>
+              <a:t>15. června 2026</a:t>
             </a:fld>
             <a:endParaRPr lang="cs-CZ"/>
           </a:p>
@@ -768,7 +768,7 @@
           <a:p>
             <a:fld id="{474C8EE8-AAF6-48AB-BE2E-E03BD44C148F}" type="datetime4">
               <a:rPr lang="cs-CZ" smtClean="0"/>
-              <a:t>9. června 2026</a:t>
+              <a:t>15. června 2026</a:t>
             </a:fld>
             <a:endParaRPr lang="cs-CZ"/>
           </a:p>
@@ -925,7 +925,7 @@
           <a:p>
             <a:fld id="{474C8EE8-AAF6-48AB-BE2E-E03BD44C148F}" type="datetime4">
               <a:rPr lang="cs-CZ" smtClean="0"/>
-              <a:t>9. června 2026</a:t>
+              <a:t>15. června 2026</a:t>
             </a:fld>
             <a:endParaRPr lang="cs-CZ"/>
           </a:p>
@@ -1070,7 +1070,7 @@
           <a:p>
             <a:fld id="{474C8EE8-AAF6-48AB-BE2E-E03BD44C148F}" type="datetime4">
               <a:rPr lang="cs-CZ" smtClean="0"/>
-              <a:t>9. června 2026</a:t>
+              <a:t>15. června 2026</a:t>
             </a:fld>
             <a:endParaRPr lang="cs-CZ"/>
           </a:p>
@@ -1483,7 +1483,7 @@
             </a:ln>
             <a:extLst>
               <a:ext uri="{C572A759-6A51-4108-AA02-DFA0A04FC94B}">
-                <ma14:wrappingTextBoxFlag xmlns:m="http://schemas.openxmlformats.org/officeDocument/2006/math" xmlns:a14="http://schemas.microsoft.com/office/drawing/2010/main" xmlns:ma14="http://schemas.microsoft.com/office/mac/drawingml/2011/main" xmlns="" val="1"/>
+                <ma14:wrappingTextBoxFlag xmlns="" xmlns:ma14="http://schemas.microsoft.com/office/mac/drawingml/2011/main" xmlns:a14="http://schemas.microsoft.com/office/drawing/2010/main" xmlns:m="http://schemas.openxmlformats.org/officeDocument/2006/math" val="1"/>
               </a:ext>
             </a:extLst>
           </p:spPr>
@@ -2081,7 +2081,7 @@
             </a:ln>
             <a:extLst>
               <a:ext uri="{C572A759-6A51-4108-AA02-DFA0A04FC94B}">
-                <ma14:wrappingTextBoxFlag xmlns:m="http://schemas.openxmlformats.org/officeDocument/2006/math" xmlns:a14="http://schemas.microsoft.com/office/drawing/2010/main" xmlns:ma14="http://schemas.microsoft.com/office/mac/drawingml/2011/main" xmlns="" val="1"/>
+                <ma14:wrappingTextBoxFlag xmlns="" xmlns:ma14="http://schemas.microsoft.com/office/mac/drawingml/2011/main" xmlns:a14="http://schemas.microsoft.com/office/drawing/2010/main" xmlns:m="http://schemas.openxmlformats.org/officeDocument/2006/math" val="1"/>
               </a:ext>
             </a:extLst>
           </p:spPr>
@@ -2493,7 +2493,7 @@
             </a:ln>
             <a:extLst>
               <a:ext uri="{C572A759-6A51-4108-AA02-DFA0A04FC94B}">
-                <ma14:wrappingTextBoxFlag xmlns:m="http://schemas.openxmlformats.org/officeDocument/2006/math" xmlns:a14="http://schemas.microsoft.com/office/drawing/2010/main" xmlns:ma14="http://schemas.microsoft.com/office/mac/drawingml/2011/main" xmlns="" val="1"/>
+                <ma14:wrappingTextBoxFlag xmlns="" xmlns:ma14="http://schemas.microsoft.com/office/mac/drawingml/2011/main" xmlns:a14="http://schemas.microsoft.com/office/drawing/2010/main" xmlns:m="http://schemas.openxmlformats.org/officeDocument/2006/math" val="1"/>
               </a:ext>
             </a:extLst>
           </p:spPr>
@@ -2942,7 +2942,7 @@
             </a:ln>
             <a:extLst>
               <a:ext uri="{C572A759-6A51-4108-AA02-DFA0A04FC94B}">
-                <ma14:wrappingTextBoxFlag xmlns:m="http://schemas.openxmlformats.org/officeDocument/2006/math" xmlns:a14="http://schemas.microsoft.com/office/drawing/2010/main" xmlns:ma14="http://schemas.microsoft.com/office/mac/drawingml/2011/main" xmlns="" val="1"/>
+                <ma14:wrappingTextBoxFlag xmlns="" xmlns:ma14="http://schemas.microsoft.com/office/mac/drawingml/2011/main" xmlns:a14="http://schemas.microsoft.com/office/drawing/2010/main" xmlns:m="http://schemas.openxmlformats.org/officeDocument/2006/math" val="1"/>
               </a:ext>
             </a:extLst>
           </p:spPr>
@@ -6052,17 +6052,6 @@
               </a:rPr>
             </a:br>
             <a:r>
-              <a:rPr lang="en-US" sz="3600" noProof="1">
-                <a:latin typeface="Quicksand"/>
-              </a:rPr>
-              <a:t>Session 2</a:t>
-            </a:r>
-            <a:br>
-              <a:rPr lang="en-US" sz="3600" noProof="1">
-                <a:latin typeface="Quicksand"/>
-              </a:rPr>
-            </a:br>
-            <a:r>
               <a:rPr lang="en-US" sz="3800" noProof="1">
                 <a:latin typeface="Quicksand"/>
               </a:rPr>
@@ -6247,17 +6236,6 @@
                 <a:latin typeface="Quicksand"/>
               </a:rPr>
             </a:br>
-            <a:br>
-              <a:rPr lang="en-US" sz="3600" noProof="1">
-                <a:latin typeface="Quicksand"/>
-              </a:rPr>
-            </a:br>
-            <a:r>
-              <a:rPr lang="en-US" sz="3600" noProof="1">
-                <a:latin typeface="Quicksand"/>
-              </a:rPr>
-              <a:t>Session 2</a:t>
-            </a:r>
             <a:br>
               <a:rPr lang="en-US" sz="3600" noProof="1">
                 <a:latin typeface="Quicksand"/>
@@ -6833,7 +6811,7 @@
             <a:fld id="{DD6F7F18-D775-4140-8128-5795D730ECEA}" type="datetime4">
               <a:rPr lang="en-US" noProof="1" smtClean="0"/>
               <a:pPr/>
-              <a:t>June 9, 2026</a:t>
+              <a:t>June 15, 2026</a:t>
             </a:fld>
             <a:endParaRPr lang="en-US" noProof="1"/>
           </a:p>
@@ -7170,7 +7148,7 @@
             <a:fld id="{DD6F7F18-D775-4140-8128-5795D730ECEA}" type="datetime4">
               <a:rPr lang="en-US" noProof="1" smtClean="0"/>
               <a:pPr/>
-              <a:t>June 9, 2026</a:t>
+              <a:t>June 15, 2026</a:t>
             </a:fld>
             <a:endParaRPr lang="en-US" noProof="1"/>
           </a:p>
@@ -8002,7 +7980,7 @@
             <a:fld id="{DD6F7F18-D775-4140-8128-5795D730ECEA}" type="datetime4">
               <a:rPr lang="en-US" noProof="1" smtClean="0"/>
               <a:pPr/>
-              <a:t>June 9, 2026</a:t>
+              <a:t>June 15, 2026</a:t>
             </a:fld>
             <a:endParaRPr lang="en-US" noProof="1"/>
           </a:p>
@@ -8565,7 +8543,7 @@
             <a:fld id="{DD6F7F18-D775-4140-8128-5795D730ECEA}" type="datetime4">
               <a:rPr lang="en-US" noProof="1" smtClean="0"/>
               <a:pPr/>
-              <a:t>June 9, 2026</a:t>
+              <a:t>June 15, 2026</a:t>
             </a:fld>
             <a:endParaRPr lang="en-US" noProof="1"/>
           </a:p>
@@ -9713,7 +9691,7 @@
             <a:fld id="{DD6F7F18-D775-4140-8128-5795D730ECEA}" type="datetime4">
               <a:rPr lang="en-US" noProof="1" smtClean="0"/>
               <a:pPr/>
-              <a:t>June 9, 2026</a:t>
+              <a:t>June 15, 2026</a:t>
             </a:fld>
             <a:endParaRPr lang="en-US" noProof="1"/>
           </a:p>
@@ -10342,7 +10320,7 @@
             <a:fld id="{DD6F7F18-D775-4140-8128-5795D730ECEA}" type="datetime4">
               <a:rPr lang="en-US" noProof="1" smtClean="0"/>
               <a:pPr/>
-              <a:t>June 9, 2026</a:t>
+              <a:t>June 15, 2026</a:t>
             </a:fld>
             <a:endParaRPr lang="en-US" noProof="1"/>
           </a:p>
@@ -10719,17 +10697,6 @@
               </a:rPr>
             </a:br>
             <a:r>
-              <a:rPr lang="en-US" sz="3600" noProof="1">
-                <a:latin typeface="Quicksand"/>
-              </a:rPr>
-              <a:t>Session 2</a:t>
-            </a:r>
-            <a:br>
-              <a:rPr lang="en-US" sz="3600" noProof="1">
-                <a:latin typeface="Quicksand"/>
-              </a:rPr>
-            </a:br>
-            <a:r>
               <a:rPr lang="en-US" sz="3800" noProof="1">
                 <a:latin typeface="Quicksand"/>
               </a:rPr>
@@ -10932,7 +10899,7 @@
             <a:fld id="{DD6F7F18-D775-4140-8128-5795D730ECEA}" type="datetime4">
               <a:rPr lang="en-US" noProof="1" smtClean="0"/>
               <a:pPr/>
-              <a:t>June 9, 2026</a:t>
+              <a:t>June 15, 2026</a:t>
             </a:fld>
             <a:endParaRPr lang="en-US" noProof="1"/>
           </a:p>
@@ -13181,18 +13148,6 @@
 </file>
 
 <file path=customXml/item1.xml><?xml version="1.0" encoding="utf-8"?>
-<p:properties xmlns:p="http://schemas.microsoft.com/office/2006/metadata/properties" xmlns:xsi="http://www.w3.org/2001/XMLSchema-instance" xmlns:pc="http://schemas.microsoft.com/office/infopath/2007/PartnerControls">
-  <documentManagement>
-    <lcf76f155ced4ddcb4097134ff3c332f xmlns="0a5a631a-9523-4ddb-aeaa-1630ff816cb5">
-      <Terms xmlns="http://schemas.microsoft.com/office/infopath/2007/PartnerControls"/>
-    </lcf76f155ced4ddcb4097134ff3c332f>
-    <TaxCatchAll xmlns="13556fe8-3232-413b-9336-036b48b41d7e" xsi:nil="true"/>
-    <hotovo_x003f_ xmlns="0a5a631a-9523-4ddb-aeaa-1630ff816cb5" xsi:nil="true"/>
-  </documentManagement>
-</p:properties>
-</file>
-
-<file path=customXml/item2.xml><?xml version="1.0" encoding="utf-8"?>
 <ct:contentTypeSchema xmlns:ct="http://schemas.microsoft.com/office/2006/metadata/contentType" xmlns:ma="http://schemas.microsoft.com/office/2006/metadata/properties/metaAttributes" ct:_="" ma:_="" ma:contentTypeName="Dokument" ma:contentTypeID="0x010100970828419A42BD479A40D9DF94C19A03" ma:contentTypeVersion="17" ma:contentTypeDescription="Vytvoří nový dokument" ma:contentTypeScope="" ma:versionID="5e4baf48c4a463bb4cb1c33487a5df65">
   <xsd:schema xmlns:xsd="http://www.w3.org/2001/XMLSchema" xmlns:xs="http://www.w3.org/2001/XMLSchema" xmlns:p="http://schemas.microsoft.com/office/2006/metadata/properties" xmlns:ns2="0a5a631a-9523-4ddb-aeaa-1630ff816cb5" xmlns:ns3="13556fe8-3232-413b-9336-036b48b41d7e" targetNamespace="http://schemas.microsoft.com/office/2006/metadata/properties" ma:root="true" ma:fieldsID="10fc0582480159263e95be47fa1e1ec8" ns2:_="" ns3:_="">
     <xsd:import namespace="0a5a631a-9523-4ddb-aeaa-1630ff816cb5"/>
@@ -13443,6 +13398,18 @@
 </ct:contentTypeSchema>
 </file>
 
+<file path=customXml/item2.xml><?xml version="1.0" encoding="utf-8"?>
+<p:properties xmlns:p="http://schemas.microsoft.com/office/2006/metadata/properties" xmlns:xsi="http://www.w3.org/2001/XMLSchema-instance" xmlns:pc="http://schemas.microsoft.com/office/infopath/2007/PartnerControls">
+  <documentManagement>
+    <lcf76f155ced4ddcb4097134ff3c332f xmlns="0a5a631a-9523-4ddb-aeaa-1630ff816cb5">
+      <Terms xmlns="http://schemas.microsoft.com/office/infopath/2007/PartnerControls"/>
+    </lcf76f155ced4ddcb4097134ff3c332f>
+    <TaxCatchAll xmlns="13556fe8-3232-413b-9336-036b48b41d7e" xsi:nil="true"/>
+    <hotovo_x003f_ xmlns="0a5a631a-9523-4ddb-aeaa-1630ff816cb5" xsi:nil="true"/>
+  </documentManagement>
+</p:properties>
+</file>
+
 <file path=customXml/item3.xml><?xml version="1.0" encoding="utf-8"?>
 <?mso-contentType ?>
 <FormTemplates xmlns="http://schemas.microsoft.com/sharepoint/v3/contenttype/forms">
@@ -13453,17 +13420,6 @@
 </file>
 
 <file path=customXml/itemProps1.xml><?xml version="1.0" encoding="utf-8"?>
-<ds:datastoreItem xmlns:ds="http://schemas.openxmlformats.org/officeDocument/2006/customXml" ds:itemID="{3F0C7F6D-654C-468D-B790-7F5AF53DAE1A}">
-  <ds:schemaRefs>
-    <ds:schemaRef ds:uri="http://schemas.microsoft.com/office/2006/metadata/properties"/>
-    <ds:schemaRef ds:uri="http://schemas.microsoft.com/office/infopath/2007/PartnerControls"/>
-    <ds:schemaRef ds:uri="0a5a631a-9523-4ddb-aeaa-1630ff816cb5"/>
-    <ds:schemaRef ds:uri="13556fe8-3232-413b-9336-036b48b41d7e"/>
-  </ds:schemaRefs>
-</ds:datastoreItem>
-</file>
-
-<file path=customXml/itemProps2.xml><?xml version="1.0" encoding="utf-8"?>
 <ds:datastoreItem xmlns:ds="http://schemas.openxmlformats.org/officeDocument/2006/customXml" ds:itemID="{73677182-B4D9-4732-9855-69FDD6BFA203}">
   <ds:schemaRefs>
     <ds:schemaRef ds:uri="http://schemas.microsoft.com/office/2006/metadata/contentType"/>
@@ -13482,6 +13438,17 @@
 </ds:datastoreItem>
 </file>
 
+<file path=customXml/itemProps2.xml><?xml version="1.0" encoding="utf-8"?>
+<ds:datastoreItem xmlns:ds="http://schemas.openxmlformats.org/officeDocument/2006/customXml" ds:itemID="{3F0C7F6D-654C-468D-B790-7F5AF53DAE1A}">
+  <ds:schemaRefs>
+    <ds:schemaRef ds:uri="http://schemas.microsoft.com/office/2006/metadata/properties"/>
+    <ds:schemaRef ds:uri="http://schemas.microsoft.com/office/infopath/2007/PartnerControls"/>
+    <ds:schemaRef ds:uri="0a5a631a-9523-4ddb-aeaa-1630ff816cb5"/>
+    <ds:schemaRef ds:uri="13556fe8-3232-413b-9336-036b48b41d7e"/>
+  </ds:schemaRefs>
+</ds:datastoreItem>
+</file>
+
 <file path=customXml/itemProps3.xml><?xml version="1.0" encoding="utf-8"?>
 <ds:datastoreItem xmlns:ds="http://schemas.openxmlformats.org/officeDocument/2006/customXml" ds:itemID="{1C13D168-7788-47A8-9181-A1FFB8C173A9}">
   <ds:schemaRefs>

</xml_diff>